<commit_message>
Anthropic-style redesign for web UI and document generators
- Updated web UI with Inter + Source Serif fonts, purple/orange accents, soft gradients
- Redesigned business card with dual accent sidebar and Anthropic color palette
- Redesigned email signature with clean layout and accent separators
- Redesigned PPTX slides with refined typography and colored accents
- Redesigned DOCX proposal with styled table headers and modern layout
- Updated brandbook.json and README screenshots

Co-Authored-By: Claude <noreply@anthropic.com>
</commit_message>
<xml_diff>
--- a/docs/presentation-example.pptx
+++ b/docs/presentation-example.pptx
@@ -3101,13 +3101,13 @@
         <p:spPr>
           <a:xfrm>
             <a:off x="0" y="0"/>
-            <a:ext cx="9144000" cy="365760"/>
+            <a:ext cx="9144000" cy="5143500"/>
           </a:xfrm>
           <a:prstGeom prst="rect">
             <a:avLst/>
           </a:prstGeom>
           <a:solidFill>
-            <a:srgbClr val="003366"/>
+            <a:srgbClr val="FAFAF8"/>
           </a:solidFill>
           <a:ln>
             <a:noFill/>
@@ -3137,143 +3137,20 @@
       </p:sp>
       <p:sp>
         <p:nvSpPr>
-          <p:cNvPr id="3" name="TextBox 2"/>
-          <p:cNvSpPr txBox="1"/>
-          <p:nvPr/>
-        </p:nvSpPr>
-        <p:spPr>
-          <a:xfrm>
-            <a:off x="640080" y="1371600"/>
-            <a:ext cx="7863840" cy="914400"/>
-          </a:xfrm>
-          <a:prstGeom prst="rect">
-            <a:avLst/>
-          </a:prstGeom>
-          <a:noFill/>
-        </p:spPr>
-        <p:txBody>
-          <a:bodyPr wrap="none">
-            <a:spAutoFit/>
-          </a:bodyPr>
-          <a:lstStyle/>
-          <a:p>
-            <a:pPr>
-              <a:defRPr sz="4000" b="1">
-                <a:solidFill>
-                  <a:srgbClr val="003366"/>
-                </a:solidFill>
-              </a:defRPr>
-            </a:pPr>
-            <a:r>
-              <a:t>Презентация для ООО РоторПром</a:t>
-            </a:r>
-          </a:p>
-        </p:txBody>
-      </p:sp>
-      <p:sp>
-        <p:nvSpPr>
-          <p:cNvPr id="4" name="TextBox 3"/>
-          <p:cNvSpPr txBox="1"/>
-          <p:nvPr/>
-        </p:nvSpPr>
-        <p:spPr>
-          <a:xfrm>
-            <a:off x="640080" y="2468880"/>
-            <a:ext cx="7863840" cy="914400"/>
-          </a:xfrm>
-          <a:prstGeom prst="rect">
-            <a:avLst/>
-          </a:prstGeom>
-          <a:noFill/>
-        </p:spPr>
-        <p:txBody>
-          <a:bodyPr wrap="none">
-            <a:spAutoFit/>
-          </a:bodyPr>
-          <a:lstStyle/>
-          <a:p>
-            <a:pPr>
-              <a:defRPr sz="2400">
-                <a:solidFill>
-                  <a:srgbClr val="1A1A1A"/>
-                </a:solidFill>
-              </a:defRPr>
-            </a:pPr>
-            <a:r>
-              <a:t>ООО ТехноДиагностика</a:t>
-            </a:r>
-          </a:p>
-        </p:txBody>
-      </p:sp>
-      <p:sp>
-        <p:nvSpPr>
-          <p:cNvPr id="5" name="TextBox 4"/>
-          <p:cNvSpPr txBox="1"/>
-          <p:nvPr/>
-        </p:nvSpPr>
-        <p:spPr>
-          <a:xfrm>
-            <a:off x="640080" y="3200400"/>
-            <a:ext cx="7863840" cy="548640"/>
-          </a:xfrm>
-          <a:prstGeom prst="rect">
-            <a:avLst/>
-          </a:prstGeom>
-          <a:noFill/>
-        </p:spPr>
-        <p:txBody>
-          <a:bodyPr wrap="none">
-            <a:spAutoFit/>
-          </a:bodyPr>
-          <a:lstStyle/>
-          <a:p>
-            <a:pPr>
-              <a:defRPr sz="1800" i="1">
-                <a:solidFill>
-                  <a:srgbClr val="00A3E0"/>
-                </a:solidFill>
-              </a:defRPr>
-            </a:pPr>
-            <a:r>
-              <a:t>Надёжная диагностика — надёжное производство</a:t>
-            </a:r>
-          </a:p>
-        </p:txBody>
-      </p:sp>
-    </p:spTree>
-  </p:cSld>
-  <p:clrMapOvr>
-    <a:masterClrMapping/>
-  </p:clrMapOvr>
-</p:sld>
-</file>
-
-<file path=ppt/slides/slide2.xml><?xml version="1.0" encoding="utf-8"?>
-<p:sld xmlns:a="http://schemas.openxmlformats.org/drawingml/2006/main" xmlns:p="http://schemas.openxmlformats.org/presentationml/2006/main" xmlns:r="http://schemas.openxmlformats.org/officeDocument/2006/relationships">
-  <p:cSld>
-    <p:spTree>
-      <p:nvGrpSpPr>
-        <p:cNvPr id="1" name=""/>
-        <p:cNvGrpSpPr/>
-        <p:nvPr/>
-      </p:nvGrpSpPr>
-      <p:grpSpPr/>
-      <p:sp>
-        <p:nvSpPr>
-          <p:cNvPr id="2" name="Rectangle 1"/>
+          <p:cNvPr id="3" name="Rectangle 2"/>
           <p:cNvSpPr/>
           <p:nvPr/>
         </p:nvSpPr>
         <p:spPr>
           <a:xfrm>
             <a:off x="0" y="0"/>
-            <a:ext cx="9144000" cy="228600"/>
+            <a:ext cx="9144000" cy="73152"/>
           </a:xfrm>
           <a:prstGeom prst="rect">
             <a:avLst/>
           </a:prstGeom>
           <a:solidFill>
-            <a:srgbClr val="003366"/>
+            <a:srgbClr val="5A4BFF"/>
           </a:solidFill>
           <a:ln>
             <a:noFill/>
@@ -3303,111 +3180,20 @@
       </p:sp>
       <p:sp>
         <p:nvSpPr>
-          <p:cNvPr id="3" name="TextBox 2"/>
-          <p:cNvSpPr txBox="1"/>
+          <p:cNvPr id="4" name="Rectangle 3"/>
+          <p:cNvSpPr/>
           <p:nvPr/>
         </p:nvSpPr>
         <p:spPr>
           <a:xfrm>
-            <a:off x="640080" y="548640"/>
-            <a:ext cx="7863840" cy="731520"/>
-          </a:xfrm>
-          <a:prstGeom prst="rect">
-            <a:avLst/>
-          </a:prstGeom>
-          <a:noFill/>
-        </p:spPr>
-        <p:txBody>
-          <a:bodyPr wrap="none">
-            <a:spAutoFit/>
-          </a:bodyPr>
-          <a:lstStyle/>
-          <a:p>
-            <a:pPr>
-              <a:defRPr sz="3200" b="1">
-                <a:solidFill>
-                  <a:srgbClr val="003366"/>
-                </a:solidFill>
-              </a:defRPr>
-            </a:pPr>
-            <a:r>
-              <a:t>Цель проекта</a:t>
-            </a:r>
-          </a:p>
-        </p:txBody>
-      </p:sp>
-      <p:sp>
-        <p:nvSpPr>
-          <p:cNvPr id="4" name="TextBox 3"/>
-          <p:cNvSpPr txBox="1"/>
-          <p:nvPr/>
-        </p:nvSpPr>
-        <p:spPr>
-          <a:xfrm>
-            <a:off x="822960" y="1463040"/>
-            <a:ext cx="7498079" cy="4572000"/>
-          </a:xfrm>
-          <a:prstGeom prst="rect">
-            <a:avLst/>
-          </a:prstGeom>
-          <a:noFill/>
-        </p:spPr>
-        <p:txBody>
-          <a:bodyPr wrap="square">
-            <a:spAutoFit/>
-          </a:bodyPr>
-          <a:lstStyle/>
-          <a:p>
-            <a:pPr>
-              <a:spcAft>
-                <a:spcPts val="1400"/>
-              </a:spcAft>
-              <a:defRPr sz="2200">
-                <a:solidFill>
-                  <a:srgbClr val="1A1A1A"/>
-                </a:solidFill>
-              </a:defRPr>
-            </a:pPr>
-            <a:r>
-              <a:t>• внедрение системы онлайн-вибродиагностики</a:t>
-            </a:r>
-          </a:p>
-        </p:txBody>
-      </p:sp>
-    </p:spTree>
-  </p:cSld>
-  <p:clrMapOvr>
-    <a:masterClrMapping/>
-  </p:clrMapOvr>
-</p:sld>
-</file>
-
-<file path=ppt/slides/slide3.xml><?xml version="1.0" encoding="utf-8"?>
-<p:sld xmlns:a="http://schemas.openxmlformats.org/drawingml/2006/main" xmlns:p="http://schemas.openxmlformats.org/presentationml/2006/main" xmlns:r="http://schemas.openxmlformats.org/officeDocument/2006/relationships">
-  <p:cSld>
-    <p:spTree>
-      <p:nvGrpSpPr>
-        <p:cNvPr id="1" name=""/>
-        <p:cNvGrpSpPr/>
-        <p:nvPr/>
-      </p:nvGrpSpPr>
-      <p:grpSpPr/>
-      <p:sp>
-        <p:nvSpPr>
-          <p:cNvPr id="2" name="Rectangle 1"/>
-          <p:cNvSpPr/>
-          <p:nvPr/>
-        </p:nvSpPr>
-        <p:spPr>
-          <a:xfrm>
-            <a:off x="0" y="0"/>
-            <a:ext cx="9144000" cy="228600"/>
+            <a:off x="0" y="5070348"/>
+            <a:ext cx="9144000" cy="73152"/>
           </a:xfrm>
           <a:prstGeom prst="rect">
             <a:avLst/>
           </a:prstGeom>
           <a:solidFill>
-            <a:srgbClr val="003366"/>
+            <a:srgbClr val="5A4BFF"/>
           </a:solidFill>
           <a:ln>
             <a:noFill/>
@@ -3437,13 +3223,48 @@
       </p:sp>
       <p:sp>
         <p:nvSpPr>
-          <p:cNvPr id="3" name="TextBox 2"/>
+          <p:cNvPr id="5" name="TextBox 4"/>
           <p:cNvSpPr txBox="1"/>
           <p:nvPr/>
         </p:nvSpPr>
         <p:spPr>
           <a:xfrm>
-            <a:off x="640080" y="548640"/>
+            <a:off x="640080" y="1645920"/>
+            <a:ext cx="7863840" cy="1097280"/>
+          </a:xfrm>
+          <a:prstGeom prst="rect">
+            <a:avLst/>
+          </a:prstGeom>
+          <a:noFill/>
+        </p:spPr>
+        <p:txBody>
+          <a:bodyPr wrap="square">
+            <a:spAutoFit/>
+          </a:bodyPr>
+          <a:lstStyle/>
+          <a:p>
+            <a:pPr>
+              <a:defRPr sz="4400" b="1">
+                <a:solidFill>
+                  <a:srgbClr val="1F1F1E"/>
+                </a:solidFill>
+              </a:defRPr>
+            </a:pPr>
+            <a:r>
+              <a:t>Презентация для ООО РоторПром</a:t>
+            </a:r>
+          </a:p>
+        </p:txBody>
+      </p:sp>
+      <p:sp>
+        <p:nvSpPr>
+          <p:cNvPr id="6" name="TextBox 5"/>
+          <p:cNvSpPr txBox="1"/>
+          <p:nvPr/>
+        </p:nvSpPr>
+        <p:spPr>
+          <a:xfrm>
+            <a:off x="640080" y="2926080"/>
             <a:ext cx="7863840" cy="731520"/>
           </a:xfrm>
           <a:prstGeom prst="rect">
@@ -3458,28 +3279,28 @@
           <a:lstStyle/>
           <a:p>
             <a:pPr>
-              <a:defRPr sz="3200" b="1">
+              <a:defRPr sz="2600">
                 <a:solidFill>
-                  <a:srgbClr val="003366"/>
+                  <a:srgbClr val="1F1F1E"/>
                 </a:solidFill>
               </a:defRPr>
             </a:pPr>
             <a:r>
-              <a:t>Почему мы</a:t>
-            </a:r>
-          </a:p>
-        </p:txBody>
-      </p:sp>
-      <p:sp>
-        <p:nvSpPr>
-          <p:cNvPr id="4" name="TextBox 3"/>
+              <a:t>ООО ТехноДиагностика</a:t>
+            </a:r>
+          </a:p>
+        </p:txBody>
+      </p:sp>
+      <p:sp>
+        <p:nvSpPr>
+          <p:cNvPr id="7" name="TextBox 6"/>
           <p:cNvSpPr txBox="1"/>
           <p:nvPr/>
         </p:nvSpPr>
         <p:spPr>
           <a:xfrm>
-            <a:off x="822960" y="1463040"/>
-            <a:ext cx="7498079" cy="4572000"/>
+            <a:off x="640080" y="3749039"/>
+            <a:ext cx="7863840" cy="548640"/>
           </a:xfrm>
           <a:prstGeom prst="rect">
             <a:avLst/>
@@ -3487,68 +3308,20 @@
           <a:noFill/>
         </p:spPr>
         <p:txBody>
-          <a:bodyPr wrap="square">
+          <a:bodyPr wrap="none">
             <a:spAutoFit/>
           </a:bodyPr>
           <a:lstStyle/>
           <a:p>
             <a:pPr>
-              <a:spcAft>
-                <a:spcPts val="1400"/>
-              </a:spcAft>
-              <a:defRPr sz="2200">
+              <a:defRPr sz="1800" i="1">
                 <a:solidFill>
-                  <a:srgbClr val="1A1A1A"/>
+                  <a:srgbClr val="5A4BFF"/>
                 </a:solidFill>
               </a:defRPr>
             </a:pPr>
             <a:r>
-              <a:t>• 15 лет опыта</a:t>
-            </a:r>
-          </a:p>
-          <a:p>
-            <a:pPr>
-              <a:spcAft>
-                <a:spcPts val="1400"/>
-              </a:spcAft>
-              <a:defRPr sz="2200">
-                <a:solidFill>
-                  <a:srgbClr val="1A1A1A"/>
-                </a:solidFill>
-              </a:defRPr>
-            </a:pPr>
-            <a:r>
-              <a:t>• более 200 внедрений</a:t>
-            </a:r>
-          </a:p>
-          <a:p>
-            <a:pPr>
-              <a:spcAft>
-                <a:spcPts val="1400"/>
-              </a:spcAft>
-              <a:defRPr sz="2200">
-                <a:solidFill>
-                  <a:srgbClr val="1A1A1A"/>
-                </a:solidFill>
-              </a:defRPr>
-            </a:pPr>
-            <a:r>
-              <a:t>• собственное производство</a:t>
-            </a:r>
-          </a:p>
-          <a:p>
-            <a:pPr>
-              <a:spcAft>
-                <a:spcPts val="1400"/>
-              </a:spcAft>
-              <a:defRPr sz="2200">
-                <a:solidFill>
-                  <a:srgbClr val="1A1A1A"/>
-                </a:solidFill>
-              </a:defRPr>
-            </a:pPr>
-            <a:r>
-              <a:t>• поддержка 24/7</a:t>
+              <a:t>Надёжная диагностика — надёжное производство</a:t>
             </a:r>
           </a:p>
         </p:txBody>
@@ -3561,7 +3334,7 @@
 </p:sld>
 </file>
 
-<file path=ppt/slides/slide4.xml><?xml version="1.0" encoding="utf-8"?>
+<file path=ppt/slides/slide2.xml><?xml version="1.0" encoding="utf-8"?>
 <p:sld xmlns:a="http://schemas.openxmlformats.org/drawingml/2006/main" xmlns:p="http://schemas.openxmlformats.org/presentationml/2006/main" xmlns:r="http://schemas.openxmlformats.org/officeDocument/2006/relationships">
   <p:cSld>
     <p:spTree>
@@ -3580,13 +3353,13 @@
         <p:spPr>
           <a:xfrm>
             <a:off x="0" y="0"/>
-            <a:ext cx="9144000" cy="228600"/>
+            <a:ext cx="9144000" cy="73152"/>
           </a:xfrm>
           <a:prstGeom prst="rect">
             <a:avLst/>
           </a:prstGeom>
           <a:solidFill>
-            <a:srgbClr val="003366"/>
+            <a:srgbClr val="5A4BFF"/>
           </a:solidFill>
           <a:ln>
             <a:noFill/>
@@ -3616,141 +3389,20 @@
       </p:sp>
       <p:sp>
         <p:nvSpPr>
-          <p:cNvPr id="3" name="TextBox 2"/>
-          <p:cNvSpPr txBox="1"/>
+          <p:cNvPr id="3" name="Rectangle 2"/>
+          <p:cNvSpPr/>
           <p:nvPr/>
         </p:nvSpPr>
         <p:spPr>
           <a:xfrm>
-            <a:off x="640080" y="548640"/>
-            <a:ext cx="7863840" cy="731520"/>
-          </a:xfrm>
-          <a:prstGeom prst="rect">
-            <a:avLst/>
-          </a:prstGeom>
-          <a:noFill/>
-        </p:spPr>
-        <p:txBody>
-          <a:bodyPr wrap="none">
-            <a:spAutoFit/>
-          </a:bodyPr>
-          <a:lstStyle/>
-          <a:p>
-            <a:pPr>
-              <a:defRPr sz="3200" b="1">
-                <a:solidFill>
-                  <a:srgbClr val="003366"/>
-                </a:solidFill>
-              </a:defRPr>
-            </a:pPr>
-            <a:r>
-              <a:t>Следующие шаги</a:t>
-            </a:r>
-          </a:p>
-        </p:txBody>
-      </p:sp>
-      <p:sp>
-        <p:nvSpPr>
-          <p:cNvPr id="4" name="TextBox 3"/>
-          <p:cNvSpPr txBox="1"/>
-          <p:nvPr/>
-        </p:nvSpPr>
-        <p:spPr>
-          <a:xfrm>
-            <a:off x="822960" y="1463040"/>
-            <a:ext cx="7498079" cy="4572000"/>
-          </a:xfrm>
-          <a:prstGeom prst="rect">
-            <a:avLst/>
-          </a:prstGeom>
-          <a:noFill/>
-        </p:spPr>
-        <p:txBody>
-          <a:bodyPr wrap="square">
-            <a:spAutoFit/>
-          </a:bodyPr>
-          <a:lstStyle/>
-          <a:p>
-            <a:pPr>
-              <a:spcAft>
-                <a:spcPts val="1400"/>
-              </a:spcAft>
-              <a:defRPr sz="2200">
-                <a:solidFill>
-                  <a:srgbClr val="1A1A1A"/>
-                </a:solidFill>
-              </a:defRPr>
-            </a:pPr>
-            <a:r>
-              <a:t>• Согласование технического задания</a:t>
-            </a:r>
-          </a:p>
-          <a:p>
-            <a:pPr>
-              <a:spcAft>
-                <a:spcPts val="1400"/>
-              </a:spcAft>
-              <a:defRPr sz="2200">
-                <a:solidFill>
-                  <a:srgbClr val="1A1A1A"/>
-                </a:solidFill>
-              </a:defRPr>
-            </a:pPr>
-            <a:r>
-              <a:t>• Подготовка коммерческого предложения</a:t>
-            </a:r>
-          </a:p>
-          <a:p>
-            <a:pPr>
-              <a:spcAft>
-                <a:spcPts val="1400"/>
-              </a:spcAft>
-              <a:defRPr sz="2200">
-                <a:solidFill>
-                  <a:srgbClr val="1A1A1A"/>
-                </a:solidFill>
-              </a:defRPr>
-            </a:pPr>
-            <a:r>
-              <a:t>• Демонстрация решения</a:t>
-            </a:r>
-          </a:p>
-        </p:txBody>
-      </p:sp>
-    </p:spTree>
-  </p:cSld>
-  <p:clrMapOvr>
-    <a:masterClrMapping/>
-  </p:clrMapOvr>
-</p:sld>
-</file>
-
-<file path=ppt/slides/slide5.xml><?xml version="1.0" encoding="utf-8"?>
-<p:sld xmlns:a="http://schemas.openxmlformats.org/drawingml/2006/main" xmlns:p="http://schemas.openxmlformats.org/presentationml/2006/main" xmlns:r="http://schemas.openxmlformats.org/officeDocument/2006/relationships">
-  <p:cSld>
-    <p:spTree>
-      <p:nvGrpSpPr>
-        <p:cNvPr id="1" name=""/>
-        <p:cNvGrpSpPr/>
-        <p:nvPr/>
-      </p:nvGrpSpPr>
-      <p:grpSpPr/>
-      <p:sp>
-        <p:nvSpPr>
-          <p:cNvPr id="2" name="Rectangle 1"/>
-          <p:cNvSpPr/>
-          <p:nvPr/>
-        </p:nvSpPr>
-        <p:spPr>
-          <a:xfrm>
-            <a:off x="0" y="0"/>
-            <a:ext cx="9144000" cy="228600"/>
+            <a:off x="502920" y="777240"/>
+            <a:ext cx="73152" cy="457200"/>
           </a:xfrm>
           <a:prstGeom prst="rect">
             <a:avLst/>
           </a:prstGeom>
           <a:solidFill>
-            <a:srgbClr val="003366"/>
+            <a:srgbClr val="FF5B24"/>
           </a:solidFill>
           <a:ln>
             <a:noFill/>
@@ -3780,13 +3432,576 @@
       </p:sp>
       <p:sp>
         <p:nvSpPr>
+          <p:cNvPr id="4" name="TextBox 3"/>
+          <p:cNvSpPr txBox="1"/>
+          <p:nvPr/>
+        </p:nvSpPr>
+        <p:spPr>
+          <a:xfrm>
+            <a:off x="685800" y="640080"/>
+            <a:ext cx="7772400" cy="731520"/>
+          </a:xfrm>
+          <a:prstGeom prst="rect">
+            <a:avLst/>
+          </a:prstGeom>
+          <a:noFill/>
+        </p:spPr>
+        <p:txBody>
+          <a:bodyPr wrap="none">
+            <a:spAutoFit/>
+          </a:bodyPr>
+          <a:lstStyle/>
+          <a:p>
+            <a:pPr>
+              <a:defRPr sz="3400" b="1">
+                <a:solidFill>
+                  <a:srgbClr val="1F1F1E"/>
+                </a:solidFill>
+              </a:defRPr>
+            </a:pPr>
+            <a:r>
+              <a:t>Цель проекта</a:t>
+            </a:r>
+          </a:p>
+        </p:txBody>
+      </p:sp>
+      <p:sp>
+        <p:nvSpPr>
+          <p:cNvPr id="5" name="TextBox 4"/>
+          <p:cNvSpPr txBox="1"/>
+          <p:nvPr/>
+        </p:nvSpPr>
+        <p:spPr>
+          <a:xfrm>
+            <a:off x="822960" y="1554480"/>
+            <a:ext cx="7498079" cy="3291840"/>
+          </a:xfrm>
+          <a:prstGeom prst="rect">
+            <a:avLst/>
+          </a:prstGeom>
+          <a:noFill/>
+        </p:spPr>
+        <p:txBody>
+          <a:bodyPr wrap="square">
+            <a:spAutoFit/>
+          </a:bodyPr>
+          <a:lstStyle/>
+          <a:p>
+            <a:pPr>
+              <a:spcAft>
+                <a:spcPts val="1600"/>
+              </a:spcAft>
+              <a:defRPr sz="2300">
+                <a:solidFill>
+                  <a:srgbClr val="1F1F1E"/>
+                </a:solidFill>
+              </a:defRPr>
+            </a:pPr>
+            <a:r>
+              <a:t>•  внедрение системы онлайн-вибродиагностики на мельничном оборудовании</a:t>
+            </a:r>
+          </a:p>
+        </p:txBody>
+      </p:sp>
+    </p:spTree>
+  </p:cSld>
+  <p:clrMapOvr>
+    <a:masterClrMapping/>
+  </p:clrMapOvr>
+</p:sld>
+</file>
+
+<file path=ppt/slides/slide3.xml><?xml version="1.0" encoding="utf-8"?>
+<p:sld xmlns:a="http://schemas.openxmlformats.org/drawingml/2006/main" xmlns:p="http://schemas.openxmlformats.org/presentationml/2006/main" xmlns:r="http://schemas.openxmlformats.org/officeDocument/2006/relationships">
+  <p:cSld>
+    <p:spTree>
+      <p:nvGrpSpPr>
+        <p:cNvPr id="1" name=""/>
+        <p:cNvGrpSpPr/>
+        <p:nvPr/>
+      </p:nvGrpSpPr>
+      <p:grpSpPr/>
+      <p:sp>
+        <p:nvSpPr>
+          <p:cNvPr id="2" name="Rectangle 1"/>
+          <p:cNvSpPr/>
+          <p:nvPr/>
+        </p:nvSpPr>
+        <p:spPr>
+          <a:xfrm>
+            <a:off x="0" y="0"/>
+            <a:ext cx="9144000" cy="73152"/>
+          </a:xfrm>
+          <a:prstGeom prst="rect">
+            <a:avLst/>
+          </a:prstGeom>
+          <a:solidFill>
+            <a:srgbClr val="5A4BFF"/>
+          </a:solidFill>
+          <a:ln>
+            <a:noFill/>
+          </a:ln>
+        </p:spPr>
+        <p:style>
+          <a:lnRef idx="1">
+            <a:schemeClr val="accent1"/>
+          </a:lnRef>
+          <a:fillRef idx="3">
+            <a:schemeClr val="accent1"/>
+          </a:fillRef>
+          <a:effectRef idx="2">
+            <a:schemeClr val="accent1"/>
+          </a:effectRef>
+          <a:fontRef idx="minor">
+            <a:schemeClr val="lt1"/>
+          </a:fontRef>
+        </p:style>
+        <p:txBody>
+          <a:bodyPr rtlCol="0" anchor="ctr"/>
+          <a:lstStyle/>
+          <a:p>
+            <a:pPr algn="ctr"/>
+          </a:p>
+        </p:txBody>
+      </p:sp>
+      <p:sp>
+        <p:nvSpPr>
+          <p:cNvPr id="3" name="Rectangle 2"/>
+          <p:cNvSpPr/>
+          <p:nvPr/>
+        </p:nvSpPr>
+        <p:spPr>
+          <a:xfrm>
+            <a:off x="502920" y="777240"/>
+            <a:ext cx="73152" cy="457200"/>
+          </a:xfrm>
+          <a:prstGeom prst="rect">
+            <a:avLst/>
+          </a:prstGeom>
+          <a:solidFill>
+            <a:srgbClr val="FF5B24"/>
+          </a:solidFill>
+          <a:ln>
+            <a:noFill/>
+          </a:ln>
+        </p:spPr>
+        <p:style>
+          <a:lnRef idx="1">
+            <a:schemeClr val="accent1"/>
+          </a:lnRef>
+          <a:fillRef idx="3">
+            <a:schemeClr val="accent1"/>
+          </a:fillRef>
+          <a:effectRef idx="2">
+            <a:schemeClr val="accent1"/>
+          </a:effectRef>
+          <a:fontRef idx="minor">
+            <a:schemeClr val="lt1"/>
+          </a:fontRef>
+        </p:style>
+        <p:txBody>
+          <a:bodyPr rtlCol="0" anchor="ctr"/>
+          <a:lstStyle/>
+          <a:p>
+            <a:pPr algn="ctr"/>
+          </a:p>
+        </p:txBody>
+      </p:sp>
+      <p:sp>
+        <p:nvSpPr>
+          <p:cNvPr id="4" name="TextBox 3"/>
+          <p:cNvSpPr txBox="1"/>
+          <p:nvPr/>
+        </p:nvSpPr>
+        <p:spPr>
+          <a:xfrm>
+            <a:off x="685800" y="640080"/>
+            <a:ext cx="7772400" cy="731520"/>
+          </a:xfrm>
+          <a:prstGeom prst="rect">
+            <a:avLst/>
+          </a:prstGeom>
+          <a:noFill/>
+        </p:spPr>
+        <p:txBody>
+          <a:bodyPr wrap="none">
+            <a:spAutoFit/>
+          </a:bodyPr>
+          <a:lstStyle/>
+          <a:p>
+            <a:pPr>
+              <a:defRPr sz="3400" b="1">
+                <a:solidFill>
+                  <a:srgbClr val="1F1F1E"/>
+                </a:solidFill>
+              </a:defRPr>
+            </a:pPr>
+            <a:r>
+              <a:t>Почему мы</a:t>
+            </a:r>
+          </a:p>
+        </p:txBody>
+      </p:sp>
+      <p:sp>
+        <p:nvSpPr>
+          <p:cNvPr id="5" name="TextBox 4"/>
+          <p:cNvSpPr txBox="1"/>
+          <p:nvPr/>
+        </p:nvSpPr>
+        <p:spPr>
+          <a:xfrm>
+            <a:off x="822960" y="1554480"/>
+            <a:ext cx="7498079" cy="3291840"/>
+          </a:xfrm>
+          <a:prstGeom prst="rect">
+            <a:avLst/>
+          </a:prstGeom>
+          <a:noFill/>
+        </p:spPr>
+        <p:txBody>
+          <a:bodyPr wrap="square">
+            <a:spAutoFit/>
+          </a:bodyPr>
+          <a:lstStyle/>
+          <a:p>
+            <a:pPr>
+              <a:spcAft>
+                <a:spcPts val="1600"/>
+              </a:spcAft>
+              <a:defRPr sz="2300">
+                <a:solidFill>
+                  <a:srgbClr val="1F1F1E"/>
+                </a:solidFill>
+              </a:defRPr>
+            </a:pPr>
+            <a:r>
+              <a:t>•  15 лет опыта в диагностике вращающегося оборудования</a:t>
+            </a:r>
+          </a:p>
+          <a:p>
+            <a:pPr>
+              <a:spcAft>
+                <a:spcPts val="1600"/>
+              </a:spcAft>
+              <a:defRPr sz="2300">
+                <a:solidFill>
+                  <a:srgbClr val="1F1F1E"/>
+                </a:solidFill>
+              </a:defRPr>
+            </a:pPr>
+            <a:r>
+              <a:t>•  более 200 успешных внедрений</a:t>
+            </a:r>
+          </a:p>
+          <a:p>
+            <a:pPr>
+              <a:spcAft>
+                <a:spcPts val="1600"/>
+              </a:spcAft>
+              <a:defRPr sz="2300">
+                <a:solidFill>
+                  <a:srgbClr val="1F1F1E"/>
+                </a:solidFill>
+              </a:defRPr>
+            </a:pPr>
+            <a:r>
+              <a:t>•  собственное производство датчиков</a:t>
+            </a:r>
+          </a:p>
+          <a:p>
+            <a:pPr>
+              <a:spcAft>
+                <a:spcPts val="1600"/>
+              </a:spcAft>
+              <a:defRPr sz="2300">
+                <a:solidFill>
+                  <a:srgbClr val="1F1F1E"/>
+                </a:solidFill>
+              </a:defRPr>
+            </a:pPr>
+            <a:r>
+              <a:t>•  техническая поддержка 24/7</a:t>
+            </a:r>
+          </a:p>
+        </p:txBody>
+      </p:sp>
+    </p:spTree>
+  </p:cSld>
+  <p:clrMapOvr>
+    <a:masterClrMapping/>
+  </p:clrMapOvr>
+</p:sld>
+</file>
+
+<file path=ppt/slides/slide4.xml><?xml version="1.0" encoding="utf-8"?>
+<p:sld xmlns:a="http://schemas.openxmlformats.org/drawingml/2006/main" xmlns:p="http://schemas.openxmlformats.org/presentationml/2006/main" xmlns:r="http://schemas.openxmlformats.org/officeDocument/2006/relationships">
+  <p:cSld>
+    <p:spTree>
+      <p:nvGrpSpPr>
+        <p:cNvPr id="1" name=""/>
+        <p:cNvGrpSpPr/>
+        <p:nvPr/>
+      </p:nvGrpSpPr>
+      <p:grpSpPr/>
+      <p:sp>
+        <p:nvSpPr>
+          <p:cNvPr id="2" name="Rectangle 1"/>
+          <p:cNvSpPr/>
+          <p:nvPr/>
+        </p:nvSpPr>
+        <p:spPr>
+          <a:xfrm>
+            <a:off x="0" y="0"/>
+            <a:ext cx="9144000" cy="73152"/>
+          </a:xfrm>
+          <a:prstGeom prst="rect">
+            <a:avLst/>
+          </a:prstGeom>
+          <a:solidFill>
+            <a:srgbClr val="5A4BFF"/>
+          </a:solidFill>
+          <a:ln>
+            <a:noFill/>
+          </a:ln>
+        </p:spPr>
+        <p:style>
+          <a:lnRef idx="1">
+            <a:schemeClr val="accent1"/>
+          </a:lnRef>
+          <a:fillRef idx="3">
+            <a:schemeClr val="accent1"/>
+          </a:fillRef>
+          <a:effectRef idx="2">
+            <a:schemeClr val="accent1"/>
+          </a:effectRef>
+          <a:fontRef idx="minor">
+            <a:schemeClr val="lt1"/>
+          </a:fontRef>
+        </p:style>
+        <p:txBody>
+          <a:bodyPr rtlCol="0" anchor="ctr"/>
+          <a:lstStyle/>
+          <a:p>
+            <a:pPr algn="ctr"/>
+          </a:p>
+        </p:txBody>
+      </p:sp>
+      <p:sp>
+        <p:nvSpPr>
+          <p:cNvPr id="3" name="Rectangle 2"/>
+          <p:cNvSpPr/>
+          <p:nvPr/>
+        </p:nvSpPr>
+        <p:spPr>
+          <a:xfrm>
+            <a:off x="502920" y="777240"/>
+            <a:ext cx="73152" cy="457200"/>
+          </a:xfrm>
+          <a:prstGeom prst="rect">
+            <a:avLst/>
+          </a:prstGeom>
+          <a:solidFill>
+            <a:srgbClr val="FF5B24"/>
+          </a:solidFill>
+          <a:ln>
+            <a:noFill/>
+          </a:ln>
+        </p:spPr>
+        <p:style>
+          <a:lnRef idx="1">
+            <a:schemeClr val="accent1"/>
+          </a:lnRef>
+          <a:fillRef idx="3">
+            <a:schemeClr val="accent1"/>
+          </a:fillRef>
+          <a:effectRef idx="2">
+            <a:schemeClr val="accent1"/>
+          </a:effectRef>
+          <a:fontRef idx="minor">
+            <a:schemeClr val="lt1"/>
+          </a:fontRef>
+        </p:style>
+        <p:txBody>
+          <a:bodyPr rtlCol="0" anchor="ctr"/>
+          <a:lstStyle/>
+          <a:p>
+            <a:pPr algn="ctr"/>
+          </a:p>
+        </p:txBody>
+      </p:sp>
+      <p:sp>
+        <p:nvSpPr>
+          <p:cNvPr id="4" name="TextBox 3"/>
+          <p:cNvSpPr txBox="1"/>
+          <p:nvPr/>
+        </p:nvSpPr>
+        <p:spPr>
+          <a:xfrm>
+            <a:off x="685800" y="640080"/>
+            <a:ext cx="7772400" cy="731520"/>
+          </a:xfrm>
+          <a:prstGeom prst="rect">
+            <a:avLst/>
+          </a:prstGeom>
+          <a:noFill/>
+        </p:spPr>
+        <p:txBody>
+          <a:bodyPr wrap="none">
+            <a:spAutoFit/>
+          </a:bodyPr>
+          <a:lstStyle/>
+          <a:p>
+            <a:pPr>
+              <a:defRPr sz="3400" b="1">
+                <a:solidFill>
+                  <a:srgbClr val="1F1F1E"/>
+                </a:solidFill>
+              </a:defRPr>
+            </a:pPr>
+            <a:r>
+              <a:t>Следующие шаги</a:t>
+            </a:r>
+          </a:p>
+        </p:txBody>
+      </p:sp>
+      <p:sp>
+        <p:nvSpPr>
+          <p:cNvPr id="5" name="TextBox 4"/>
+          <p:cNvSpPr txBox="1"/>
+          <p:nvPr/>
+        </p:nvSpPr>
+        <p:spPr>
+          <a:xfrm>
+            <a:off x="822960" y="1554480"/>
+            <a:ext cx="7498079" cy="3291840"/>
+          </a:xfrm>
+          <a:prstGeom prst="rect">
+            <a:avLst/>
+          </a:prstGeom>
+          <a:noFill/>
+        </p:spPr>
+        <p:txBody>
+          <a:bodyPr wrap="square">
+            <a:spAutoFit/>
+          </a:bodyPr>
+          <a:lstStyle/>
+          <a:p>
+            <a:pPr>
+              <a:spcAft>
+                <a:spcPts val="1600"/>
+              </a:spcAft>
+              <a:defRPr sz="2300">
+                <a:solidFill>
+                  <a:srgbClr val="1F1F1E"/>
+                </a:solidFill>
+              </a:defRPr>
+            </a:pPr>
+            <a:r>
+              <a:t>•  Согласование технического задания</a:t>
+            </a:r>
+          </a:p>
+          <a:p>
+            <a:pPr>
+              <a:spcAft>
+                <a:spcPts val="1600"/>
+              </a:spcAft>
+              <a:defRPr sz="2300">
+                <a:solidFill>
+                  <a:srgbClr val="1F1F1E"/>
+                </a:solidFill>
+              </a:defRPr>
+            </a:pPr>
+            <a:r>
+              <a:t>•  Подготовка коммерческого предложения</a:t>
+            </a:r>
+          </a:p>
+          <a:p>
+            <a:pPr>
+              <a:spcAft>
+                <a:spcPts val="1600"/>
+              </a:spcAft>
+              <a:defRPr sz="2300">
+                <a:solidFill>
+                  <a:srgbClr val="1F1F1E"/>
+                </a:solidFill>
+              </a:defRPr>
+            </a:pPr>
+            <a:r>
+              <a:t>•  Демонстрация решения</a:t>
+            </a:r>
+          </a:p>
+        </p:txBody>
+      </p:sp>
+    </p:spTree>
+  </p:cSld>
+  <p:clrMapOvr>
+    <a:masterClrMapping/>
+  </p:clrMapOvr>
+</p:sld>
+</file>
+
+<file path=ppt/slides/slide5.xml><?xml version="1.0" encoding="utf-8"?>
+<p:sld xmlns:a="http://schemas.openxmlformats.org/drawingml/2006/main" xmlns:p="http://schemas.openxmlformats.org/presentationml/2006/main" xmlns:r="http://schemas.openxmlformats.org/officeDocument/2006/relationships">
+  <p:cSld>
+    <p:spTree>
+      <p:nvGrpSpPr>
+        <p:cNvPr id="1" name=""/>
+        <p:cNvGrpSpPr/>
+        <p:nvPr/>
+      </p:nvGrpSpPr>
+      <p:grpSpPr/>
+      <p:sp>
+        <p:nvSpPr>
+          <p:cNvPr id="2" name="Rectangle 1"/>
+          <p:cNvSpPr/>
+          <p:nvPr/>
+        </p:nvSpPr>
+        <p:spPr>
+          <a:xfrm>
+            <a:off x="0" y="0"/>
+            <a:ext cx="9144000" cy="5143500"/>
+          </a:xfrm>
+          <a:prstGeom prst="rect">
+            <a:avLst/>
+          </a:prstGeom>
+          <a:solidFill>
+            <a:srgbClr val="5A4BFF"/>
+          </a:solidFill>
+          <a:ln>
+            <a:noFill/>
+          </a:ln>
+        </p:spPr>
+        <p:style>
+          <a:lnRef idx="1">
+            <a:schemeClr val="accent1"/>
+          </a:lnRef>
+          <a:fillRef idx="3">
+            <a:schemeClr val="accent1"/>
+          </a:fillRef>
+          <a:effectRef idx="2">
+            <a:schemeClr val="accent1"/>
+          </a:effectRef>
+          <a:fontRef idx="minor">
+            <a:schemeClr val="lt1"/>
+          </a:fontRef>
+        </p:style>
+        <p:txBody>
+          <a:bodyPr rtlCol="0" anchor="ctr"/>
+          <a:lstStyle/>
+          <a:p>
+            <a:pPr algn="ctr"/>
+          </a:p>
+        </p:txBody>
+      </p:sp>
+      <p:sp>
+        <p:nvSpPr>
           <p:cNvPr id="3" name="TextBox 2"/>
           <p:cNvSpPr txBox="1"/>
           <p:nvPr/>
         </p:nvSpPr>
         <p:spPr>
           <a:xfrm>
-            <a:off x="640080" y="548640"/>
+            <a:off x="640080" y="822960"/>
             <a:ext cx="7863840" cy="731520"/>
           </a:xfrm>
           <a:prstGeom prst="rect">
@@ -3801,14 +4016,14 @@
           <a:lstStyle/>
           <a:p>
             <a:pPr>
-              <a:defRPr sz="3200" b="1">
+              <a:defRPr sz="3600" b="1">
                 <a:solidFill>
-                  <a:srgbClr val="003366"/>
+                  <a:srgbClr val="FFFFFF"/>
                 </a:solidFill>
               </a:defRPr>
             </a:pPr>
             <a:r>
-              <a:t>Контакты</a:t>
+              <a:t>Свяжитесь с нами</a:t>
             </a:r>
           </a:p>
         </p:txBody>
@@ -3821,8 +4036,8 @@
         </p:nvSpPr>
         <p:spPr>
           <a:xfrm>
-            <a:off x="822960" y="1463040"/>
-            <a:ext cx="7498079" cy="4572000"/>
+            <a:off x="822960" y="1828800"/>
+            <a:ext cx="7498079" cy="2926080"/>
           </a:xfrm>
           <a:prstGeom prst="rect">
             <a:avLst/>
@@ -3841,7 +4056,7 @@
               </a:spcAft>
               <a:defRPr sz="2400">
                 <a:solidFill>
-                  <a:srgbClr val="1A1A1A"/>
+                  <a:srgbClr val="FFFFFF"/>
                 </a:solidFill>
               </a:defRPr>
             </a:pPr>
@@ -3856,7 +4071,7 @@
               </a:spcAft>
               <a:defRPr sz="2400">
                 <a:solidFill>
-                  <a:srgbClr val="1A1A1A"/>
+                  <a:srgbClr val="FFFFFF"/>
                 </a:solidFill>
               </a:defRPr>
             </a:pPr>
@@ -3871,7 +4086,7 @@
               </a:spcAft>
               <a:defRPr sz="2400">
                 <a:solidFill>
-                  <a:srgbClr val="1A1A1A"/>
+                  <a:srgbClr val="FFFFFF"/>
                 </a:solidFill>
               </a:defRPr>
             </a:pPr>
@@ -3886,7 +4101,7 @@
               </a:spcAft>
               <a:defRPr sz="2400">
                 <a:solidFill>
-                  <a:srgbClr val="1A1A1A"/>
+                  <a:srgbClr val="FFFFFF"/>
                 </a:solidFill>
               </a:defRPr>
             </a:pPr>
@@ -3901,7 +4116,7 @@
               </a:spcAft>
               <a:defRPr sz="2400">
                 <a:solidFill>
-                  <a:srgbClr val="1A1A1A"/>
+                  <a:srgbClr val="FFFFFF"/>
                 </a:solidFill>
               </a:defRPr>
             </a:pPr>

</xml_diff>

<commit_message>
feat: logo upload and rendering in all materials
- Add optional logo upload to /api/brandbook and web UI
- Render logo in business cards, presentations, proposals and email signatures
- Add SVG-to-PNG conversion via svglib/rlPyCairo for print materials
- Add --logo flag to CLI upload-brandbook command
- Update README and regenerate docs examples

Co-Authored-By: Claude <noreply@anthropic.com>
</commit_message>
<xml_diff>
--- a/docs/presentation-example.pptx
+++ b/docs/presentation-example.pptx
@@ -8,8 +8,6 @@
     <p:sldId id="256" r:id="rId7"/>
     <p:sldId id="257" r:id="rId8"/>
     <p:sldId id="258" r:id="rId9"/>
-    <p:sldId id="259" r:id="rId10"/>
-    <p:sldId id="260" r:id="rId11"/>
   </p:sldIdLst>
   <p:sldSz cx="9144000" cy="5143500" type="screen4x3"/>
   <p:notesSz cx="6858000" cy="9144000"/>
@@ -3085,6 +3083,14 @@
 <file path=ppt/slides/slide1.xml><?xml version="1.0" encoding="utf-8"?>
 <p:sld xmlns:a="http://schemas.openxmlformats.org/drawingml/2006/main" xmlns:p="http://schemas.openxmlformats.org/presentationml/2006/main" xmlns:r="http://schemas.openxmlformats.org/officeDocument/2006/relationships">
   <p:cSld>
+    <p:bg>
+      <p:bgPr>
+        <a:solidFill>
+          <a:srgbClr val="FAFAF8"/>
+        </a:solidFill>
+        <a:effectLst/>
+      </p:bgPr>
+    </p:bg>
     <p:spTree>
       <p:nvGrpSpPr>
         <p:cNvPr id="1" name=""/>
@@ -3095,49 +3101,6 @@
       <p:sp>
         <p:nvSpPr>
           <p:cNvPr id="2" name="Rectangle 1"/>
-          <p:cNvSpPr/>
-          <p:nvPr/>
-        </p:nvSpPr>
-        <p:spPr>
-          <a:xfrm>
-            <a:off x="0" y="0"/>
-            <a:ext cx="9144000" cy="5143500"/>
-          </a:xfrm>
-          <a:prstGeom prst="rect">
-            <a:avLst/>
-          </a:prstGeom>
-          <a:solidFill>
-            <a:srgbClr val="FAFAF8"/>
-          </a:solidFill>
-          <a:ln>
-            <a:noFill/>
-          </a:ln>
-        </p:spPr>
-        <p:style>
-          <a:lnRef idx="1">
-            <a:schemeClr val="accent1"/>
-          </a:lnRef>
-          <a:fillRef idx="3">
-            <a:schemeClr val="accent1"/>
-          </a:fillRef>
-          <a:effectRef idx="2">
-            <a:schemeClr val="accent1"/>
-          </a:effectRef>
-          <a:fontRef idx="minor">
-            <a:schemeClr val="lt1"/>
-          </a:fontRef>
-        </p:style>
-        <p:txBody>
-          <a:bodyPr rtlCol="0" anchor="ctr"/>
-          <a:lstStyle/>
-          <a:p>
-            <a:pPr algn="ctr"/>
-          </a:p>
-        </p:txBody>
-      </p:sp>
-      <p:sp>
-        <p:nvSpPr>
-          <p:cNvPr id="3" name="Rectangle 2"/>
           <p:cNvSpPr/>
           <p:nvPr/>
         </p:nvSpPr>
@@ -3180,7 +3143,7 @@
       </p:sp>
       <p:sp>
         <p:nvSpPr>
-          <p:cNvPr id="4" name="Rectangle 3"/>
+          <p:cNvPr id="3" name="Rectangle 2"/>
           <p:cNvSpPr/>
           <p:nvPr/>
         </p:nvSpPr>
@@ -3221,6 +3184,30 @@
           </a:p>
         </p:txBody>
       </p:sp>
+      <p:pic>
+        <p:nvPicPr>
+          <p:cNvPr id="4" name="Picture 3" descr="logo.png"/>
+          <p:cNvPicPr>
+            <a:picLocks noChangeAspect="1"/>
+          </p:cNvPicPr>
+          <p:nvPr/>
+        </p:nvPicPr>
+        <p:blipFill>
+          <a:blip r:embed="rId2"/>
+          <a:stretch>
+            <a:fillRect/>
+          </a:stretch>
+        </p:blipFill>
+        <p:spPr>
+          <a:xfrm>
+            <a:off x="7101840" y="228600"/>
+            <a:ext cx="1676400" cy="502920"/>
+          </a:xfrm>
+          <a:prstGeom prst="rect">
+            <a:avLst/>
+          </a:prstGeom>
+        </p:spPr>
+      </p:pic>
       <p:sp>
         <p:nvSpPr>
           <p:cNvPr id="5" name="TextBox 4"/>
@@ -3229,7 +3216,7 @@
         </p:nvSpPr>
         <p:spPr>
           <a:xfrm>
-            <a:off x="640080" y="1645920"/>
+            <a:off x="640080" y="1737360"/>
             <a:ext cx="7863840" cy="1097280"/>
           </a:xfrm>
           <a:prstGeom prst="rect">
@@ -3264,7 +3251,7 @@
         </p:nvSpPr>
         <p:spPr>
           <a:xfrm>
-            <a:off x="640080" y="2926080"/>
+            <a:off x="640080" y="3017520"/>
             <a:ext cx="7863840" cy="731520"/>
           </a:xfrm>
           <a:prstGeom prst="rect">
@@ -3299,7 +3286,7 @@
         </p:nvSpPr>
         <p:spPr>
           <a:xfrm>
-            <a:off x="640080" y="3749039"/>
+            <a:off x="640080" y="3840480"/>
             <a:ext cx="7863840" cy="548640"/>
           </a:xfrm>
           <a:prstGeom prst="rect">
@@ -3337,6 +3324,14 @@
 <file path=ppt/slides/slide2.xml><?xml version="1.0" encoding="utf-8"?>
 <p:sld xmlns:a="http://schemas.openxmlformats.org/drawingml/2006/main" xmlns:p="http://schemas.openxmlformats.org/presentationml/2006/main" xmlns:r="http://schemas.openxmlformats.org/officeDocument/2006/relationships">
   <p:cSld>
+    <p:bg>
+      <p:bgPr>
+        <a:solidFill>
+          <a:srgbClr val="FAFAF8"/>
+        </a:solidFill>
+        <a:effectLst/>
+      </p:bgPr>
+    </p:bg>
     <p:spTree>
       <p:nvGrpSpPr>
         <p:cNvPr id="1" name=""/>
@@ -3387,9 +3382,33 @@
           </a:p>
         </p:txBody>
       </p:sp>
-      <p:sp>
-        <p:nvSpPr>
-          <p:cNvPr id="3" name="Rectangle 2"/>
+      <p:pic>
+        <p:nvPicPr>
+          <p:cNvPr id="3" name="Picture 2" descr="logo.png"/>
+          <p:cNvPicPr>
+            <a:picLocks noChangeAspect="1"/>
+          </p:cNvPicPr>
+          <p:nvPr/>
+        </p:nvPicPr>
+        <p:blipFill>
+          <a:blip r:embed="rId2"/>
+          <a:stretch>
+            <a:fillRect/>
+          </a:stretch>
+        </p:blipFill>
+        <p:spPr>
+          <a:xfrm>
+            <a:off x="7101840" y="228600"/>
+            <a:ext cx="1676400" cy="502920"/>
+          </a:xfrm>
+          <a:prstGeom prst="rect">
+            <a:avLst/>
+          </a:prstGeom>
+        </p:spPr>
+      </p:pic>
+      <p:sp>
+        <p:nvSpPr>
+          <p:cNvPr id="4" name="Rectangle 3"/>
           <p:cNvSpPr/>
           <p:nvPr/>
         </p:nvSpPr>
@@ -3432,7 +3451,7 @@
       </p:sp>
       <p:sp>
         <p:nvSpPr>
-          <p:cNvPr id="4" name="TextBox 3"/>
+          <p:cNvPr id="5" name="TextBox 4"/>
           <p:cNvSpPr txBox="1"/>
           <p:nvPr/>
         </p:nvSpPr>
@@ -3460,14 +3479,14 @@
               </a:defRPr>
             </a:pPr>
             <a:r>
-              <a:t>Цель проекта</a:t>
-            </a:r>
-          </a:p>
-        </p:txBody>
-      </p:sp>
-      <p:sp>
-        <p:nvSpPr>
-          <p:cNvPr id="5" name="TextBox 4"/>
+              <a:t>Следующие шаги</a:t>
+            </a:r>
+          </a:p>
+        </p:txBody>
+      </p:sp>
+      <p:sp>
+        <p:nvSpPr>
+          <p:cNvPr id="6" name="TextBox 5"/>
           <p:cNvSpPr txBox="1"/>
           <p:nvPr/>
         </p:nvSpPr>
@@ -3498,7 +3517,37 @@
               </a:defRPr>
             </a:pPr>
             <a:r>
-              <a:t>•  внедрение системы онлайн-вибродиагностики на мельничном оборудовании</a:t>
+              <a:t>•  Согласование технического задания</a:t>
+            </a:r>
+          </a:p>
+          <a:p>
+            <a:pPr>
+              <a:spcAft>
+                <a:spcPts val="1600"/>
+              </a:spcAft>
+              <a:defRPr sz="2300">
+                <a:solidFill>
+                  <a:srgbClr val="1F1F1E"/>
+                </a:solidFill>
+              </a:defRPr>
+            </a:pPr>
+            <a:r>
+              <a:t>•  Подготовка коммерческого предложения</a:t>
+            </a:r>
+          </a:p>
+          <a:p>
+            <a:pPr>
+              <a:spcAft>
+                <a:spcPts val="1600"/>
+              </a:spcAft>
+              <a:defRPr sz="2300">
+                <a:solidFill>
+                  <a:srgbClr val="1F1F1E"/>
+                </a:solidFill>
+              </a:defRPr>
+            </a:pPr>
+            <a:r>
+              <a:t>•  Демонстрация решения</a:t>
             </a:r>
           </a:p>
         </p:txBody>
@@ -3514,6 +3563,14 @@
 <file path=ppt/slides/slide3.xml><?xml version="1.0" encoding="utf-8"?>
 <p:sld xmlns:a="http://schemas.openxmlformats.org/drawingml/2006/main" xmlns:p="http://schemas.openxmlformats.org/presentationml/2006/main" xmlns:r="http://schemas.openxmlformats.org/officeDocument/2006/relationships">
   <p:cSld>
+    <p:bg>
+      <p:bgPr>
+        <a:solidFill>
+          <a:srgbClr val="FAFAF8"/>
+        </a:solidFill>
+        <a:effectLst/>
+      </p:bgPr>
+    </p:bg>
     <p:spTree>
       <p:nvGrpSpPr>
         <p:cNvPr id="1" name=""/>
@@ -3530,7 +3587,7 @@
         <p:spPr>
           <a:xfrm>
             <a:off x="0" y="0"/>
-            <a:ext cx="9144000" cy="73152"/>
+            <a:ext cx="3840480" cy="5143500"/>
           </a:xfrm>
           <a:prstGeom prst="rect">
             <a:avLst/>
@@ -3566,57 +3623,14 @@
       </p:sp>
       <p:sp>
         <p:nvSpPr>
-          <p:cNvPr id="3" name="Rectangle 2"/>
-          <p:cNvSpPr/>
+          <p:cNvPr id="3" name="TextBox 2"/>
+          <p:cNvSpPr txBox="1"/>
           <p:nvPr/>
         </p:nvSpPr>
         <p:spPr>
           <a:xfrm>
-            <a:off x="502920" y="777240"/>
-            <a:ext cx="73152" cy="457200"/>
-          </a:xfrm>
-          <a:prstGeom prst="rect">
-            <a:avLst/>
-          </a:prstGeom>
-          <a:solidFill>
-            <a:srgbClr val="FF5B24"/>
-          </a:solidFill>
-          <a:ln>
-            <a:noFill/>
-          </a:ln>
-        </p:spPr>
-        <p:style>
-          <a:lnRef idx="1">
-            <a:schemeClr val="accent1"/>
-          </a:lnRef>
-          <a:fillRef idx="3">
-            <a:schemeClr val="accent1"/>
-          </a:fillRef>
-          <a:effectRef idx="2">
-            <a:schemeClr val="accent1"/>
-          </a:effectRef>
-          <a:fontRef idx="minor">
-            <a:schemeClr val="lt1"/>
-          </a:fontRef>
-        </p:style>
-        <p:txBody>
-          <a:bodyPr rtlCol="0" anchor="ctr"/>
-          <a:lstStyle/>
-          <a:p>
-            <a:pPr algn="ctr"/>
-          </a:p>
-        </p:txBody>
-      </p:sp>
-      <p:sp>
-        <p:nvSpPr>
-          <p:cNvPr id="4" name="TextBox 3"/>
-          <p:cNvSpPr txBox="1"/>
-          <p:nvPr/>
-        </p:nvSpPr>
-        <p:spPr>
-          <a:xfrm>
-            <a:off x="685800" y="640080"/>
-            <a:ext cx="7772400" cy="731520"/>
+            <a:off x="548640" y="914400"/>
+            <a:ext cx="3108960" cy="822960"/>
           </a:xfrm>
           <a:prstGeom prst="rect">
             <a:avLst/>
@@ -3630,28 +3644,28 @@
           <a:lstStyle/>
           <a:p>
             <a:pPr>
-              <a:defRPr sz="3400" b="1">
+              <a:defRPr sz="3000" b="1">
                 <a:solidFill>
-                  <a:srgbClr val="1F1F1E"/>
+                  <a:srgbClr val="FFFFFF"/>
                 </a:solidFill>
               </a:defRPr>
             </a:pPr>
             <a:r>
-              <a:t>Почему мы</a:t>
-            </a:r>
-          </a:p>
-        </p:txBody>
-      </p:sp>
-      <p:sp>
-        <p:nvSpPr>
-          <p:cNvPr id="5" name="TextBox 4"/>
+              <a:t>Свяжитесь с нами</a:t>
+            </a:r>
+          </a:p>
+        </p:txBody>
+      </p:sp>
+      <p:sp>
+        <p:nvSpPr>
+          <p:cNvPr id="4" name="TextBox 3"/>
           <p:cNvSpPr txBox="1"/>
           <p:nvPr/>
         </p:nvSpPr>
         <p:spPr>
           <a:xfrm>
-            <a:off x="822960" y="1554480"/>
-            <a:ext cx="7498079" cy="3291840"/>
+            <a:off x="548640" y="1920240"/>
+            <a:ext cx="3108960" cy="2743200"/>
           </a:xfrm>
           <a:prstGeom prst="rect">
             <a:avLst/>
@@ -3666,466 +3680,104 @@
           <a:p>
             <a:pPr>
               <a:spcAft>
-                <a:spcPts val="1600"/>
+                <a:spcPts val="1000"/>
               </a:spcAft>
-              <a:defRPr sz="2300">
-                <a:solidFill>
-                  <a:srgbClr val="1F1F1E"/>
-                </a:solidFill>
-              </a:defRPr>
-            </a:pPr>
-            <a:r>
-              <a:t>•  15 лет опыта в диагностике вращающегося оборудования</a:t>
-            </a:r>
-          </a:p>
-          <a:p>
-            <a:pPr>
-              <a:spcAft>
-                <a:spcPts val="1600"/>
-              </a:spcAft>
-              <a:defRPr sz="2300">
-                <a:solidFill>
-                  <a:srgbClr val="1F1F1E"/>
-                </a:solidFill>
-              </a:defRPr>
-            </a:pPr>
-            <a:r>
-              <a:t>•  более 200 успешных внедрений</a:t>
-            </a:r>
-          </a:p>
-          <a:p>
-            <a:pPr>
-              <a:spcAft>
-                <a:spcPts val="1600"/>
-              </a:spcAft>
-              <a:defRPr sz="2300">
-                <a:solidFill>
-                  <a:srgbClr val="1F1F1E"/>
-                </a:solidFill>
-              </a:defRPr>
-            </a:pPr>
-            <a:r>
-              <a:t>•  собственное производство датчиков</a:t>
-            </a:r>
-          </a:p>
-          <a:p>
-            <a:pPr>
-              <a:spcAft>
-                <a:spcPts val="1600"/>
-              </a:spcAft>
-              <a:defRPr sz="2300">
-                <a:solidFill>
-                  <a:srgbClr val="1F1F1E"/>
-                </a:solidFill>
-              </a:defRPr>
-            </a:pPr>
-            <a:r>
-              <a:t>•  техническая поддержка 24/7</a:t>
-            </a:r>
-          </a:p>
-        </p:txBody>
-      </p:sp>
-    </p:spTree>
-  </p:cSld>
-  <p:clrMapOvr>
-    <a:masterClrMapping/>
-  </p:clrMapOvr>
-</p:sld>
-</file>
-
-<file path=ppt/slides/slide4.xml><?xml version="1.0" encoding="utf-8"?>
-<p:sld xmlns:a="http://schemas.openxmlformats.org/drawingml/2006/main" xmlns:p="http://schemas.openxmlformats.org/presentationml/2006/main" xmlns:r="http://schemas.openxmlformats.org/officeDocument/2006/relationships">
-  <p:cSld>
-    <p:spTree>
-      <p:nvGrpSpPr>
-        <p:cNvPr id="1" name=""/>
-        <p:cNvGrpSpPr/>
-        <p:nvPr/>
-      </p:nvGrpSpPr>
-      <p:grpSpPr/>
-      <p:sp>
-        <p:nvSpPr>
-          <p:cNvPr id="2" name="Rectangle 1"/>
-          <p:cNvSpPr/>
-          <p:nvPr/>
-        </p:nvSpPr>
-        <p:spPr>
-          <a:xfrm>
-            <a:off x="0" y="0"/>
-            <a:ext cx="9144000" cy="73152"/>
-          </a:xfrm>
-          <a:prstGeom prst="rect">
-            <a:avLst/>
-          </a:prstGeom>
-          <a:solidFill>
-            <a:srgbClr val="5A4BFF"/>
-          </a:solidFill>
-          <a:ln>
-            <a:noFill/>
-          </a:ln>
-        </p:spPr>
-        <p:style>
-          <a:lnRef idx="1">
-            <a:schemeClr val="accent1"/>
-          </a:lnRef>
-          <a:fillRef idx="3">
-            <a:schemeClr val="accent1"/>
-          </a:fillRef>
-          <a:effectRef idx="2">
-            <a:schemeClr val="accent1"/>
-          </a:effectRef>
-          <a:fontRef idx="minor">
-            <a:schemeClr val="lt1"/>
-          </a:fontRef>
-        </p:style>
-        <p:txBody>
-          <a:bodyPr rtlCol="0" anchor="ctr"/>
-          <a:lstStyle/>
-          <a:p>
-            <a:pPr algn="ctr"/>
-          </a:p>
-        </p:txBody>
-      </p:sp>
-      <p:sp>
-        <p:nvSpPr>
-          <p:cNvPr id="3" name="Rectangle 2"/>
-          <p:cNvSpPr/>
-          <p:nvPr/>
-        </p:nvSpPr>
-        <p:spPr>
-          <a:xfrm>
-            <a:off x="502920" y="777240"/>
-            <a:ext cx="73152" cy="457200"/>
-          </a:xfrm>
-          <a:prstGeom prst="rect">
-            <a:avLst/>
-          </a:prstGeom>
-          <a:solidFill>
-            <a:srgbClr val="FF5B24"/>
-          </a:solidFill>
-          <a:ln>
-            <a:noFill/>
-          </a:ln>
-        </p:spPr>
-        <p:style>
-          <a:lnRef idx="1">
-            <a:schemeClr val="accent1"/>
-          </a:lnRef>
-          <a:fillRef idx="3">
-            <a:schemeClr val="accent1"/>
-          </a:fillRef>
-          <a:effectRef idx="2">
-            <a:schemeClr val="accent1"/>
-          </a:effectRef>
-          <a:fontRef idx="minor">
-            <a:schemeClr val="lt1"/>
-          </a:fontRef>
-        </p:style>
-        <p:txBody>
-          <a:bodyPr rtlCol="0" anchor="ctr"/>
-          <a:lstStyle/>
-          <a:p>
-            <a:pPr algn="ctr"/>
-          </a:p>
-        </p:txBody>
-      </p:sp>
-      <p:sp>
-        <p:nvSpPr>
-          <p:cNvPr id="4" name="TextBox 3"/>
-          <p:cNvSpPr txBox="1"/>
-          <p:nvPr/>
-        </p:nvSpPr>
-        <p:spPr>
-          <a:xfrm>
-            <a:off x="685800" y="640080"/>
-            <a:ext cx="7772400" cy="731520"/>
-          </a:xfrm>
-          <a:prstGeom prst="rect">
-            <a:avLst/>
-          </a:prstGeom>
-          <a:noFill/>
-        </p:spPr>
-        <p:txBody>
-          <a:bodyPr wrap="none">
-            <a:spAutoFit/>
-          </a:bodyPr>
-          <a:lstStyle/>
-          <a:p>
-            <a:pPr>
-              <a:defRPr sz="3400" b="1">
-                <a:solidFill>
-                  <a:srgbClr val="1F1F1E"/>
-                </a:solidFill>
-              </a:defRPr>
-            </a:pPr>
-            <a:r>
-              <a:t>Следующие шаги</a:t>
-            </a:r>
-          </a:p>
-        </p:txBody>
-      </p:sp>
-      <p:sp>
-        <p:nvSpPr>
-          <p:cNvPr id="5" name="TextBox 4"/>
-          <p:cNvSpPr txBox="1"/>
-          <p:nvPr/>
-        </p:nvSpPr>
-        <p:spPr>
-          <a:xfrm>
-            <a:off x="822960" y="1554480"/>
-            <a:ext cx="7498079" cy="3291840"/>
-          </a:xfrm>
-          <a:prstGeom prst="rect">
-            <a:avLst/>
-          </a:prstGeom>
-          <a:noFill/>
-        </p:spPr>
-        <p:txBody>
-          <a:bodyPr wrap="square">
-            <a:spAutoFit/>
-          </a:bodyPr>
-          <a:lstStyle/>
-          <a:p>
-            <a:pPr>
-              <a:spcAft>
-                <a:spcPts val="1600"/>
-              </a:spcAft>
-              <a:defRPr sz="2300">
-                <a:solidFill>
-                  <a:srgbClr val="1F1F1E"/>
-                </a:solidFill>
-              </a:defRPr>
-            </a:pPr>
-            <a:r>
-              <a:t>•  Согласование технического задания</a:t>
-            </a:r>
-          </a:p>
-          <a:p>
-            <a:pPr>
-              <a:spcAft>
-                <a:spcPts val="1600"/>
-              </a:spcAft>
-              <a:defRPr sz="2300">
-                <a:solidFill>
-                  <a:srgbClr val="1F1F1E"/>
-                </a:solidFill>
-              </a:defRPr>
-            </a:pPr>
-            <a:r>
-              <a:t>•  Подготовка коммерческого предложения</a:t>
-            </a:r>
-          </a:p>
-          <a:p>
-            <a:pPr>
-              <a:spcAft>
-                <a:spcPts val="1600"/>
-              </a:spcAft>
-              <a:defRPr sz="2300">
-                <a:solidFill>
-                  <a:srgbClr val="1F1F1E"/>
-                </a:solidFill>
-              </a:defRPr>
-            </a:pPr>
-            <a:r>
-              <a:t>•  Демонстрация решения</a:t>
-            </a:r>
-          </a:p>
-        </p:txBody>
-      </p:sp>
-    </p:spTree>
-  </p:cSld>
-  <p:clrMapOvr>
-    <a:masterClrMapping/>
-  </p:clrMapOvr>
-</p:sld>
-</file>
-
-<file path=ppt/slides/slide5.xml><?xml version="1.0" encoding="utf-8"?>
-<p:sld xmlns:a="http://schemas.openxmlformats.org/drawingml/2006/main" xmlns:p="http://schemas.openxmlformats.org/presentationml/2006/main" xmlns:r="http://schemas.openxmlformats.org/officeDocument/2006/relationships">
-  <p:cSld>
-    <p:spTree>
-      <p:nvGrpSpPr>
-        <p:cNvPr id="1" name=""/>
-        <p:cNvGrpSpPr/>
-        <p:nvPr/>
-      </p:nvGrpSpPr>
-      <p:grpSpPr/>
-      <p:sp>
-        <p:nvSpPr>
-          <p:cNvPr id="2" name="Rectangle 1"/>
-          <p:cNvSpPr/>
-          <p:nvPr/>
-        </p:nvSpPr>
-        <p:spPr>
-          <a:xfrm>
-            <a:off x="0" y="0"/>
-            <a:ext cx="9144000" cy="5143500"/>
-          </a:xfrm>
-          <a:prstGeom prst="rect">
-            <a:avLst/>
-          </a:prstGeom>
-          <a:solidFill>
-            <a:srgbClr val="5A4BFF"/>
-          </a:solidFill>
-          <a:ln>
-            <a:noFill/>
-          </a:ln>
-        </p:spPr>
-        <p:style>
-          <a:lnRef idx="1">
-            <a:schemeClr val="accent1"/>
-          </a:lnRef>
-          <a:fillRef idx="3">
-            <a:schemeClr val="accent1"/>
-          </a:fillRef>
-          <a:effectRef idx="2">
-            <a:schemeClr val="accent1"/>
-          </a:effectRef>
-          <a:fontRef idx="minor">
-            <a:schemeClr val="lt1"/>
-          </a:fontRef>
-        </p:style>
-        <p:txBody>
-          <a:bodyPr rtlCol="0" anchor="ctr"/>
-          <a:lstStyle/>
-          <a:p>
-            <a:pPr algn="ctr"/>
-          </a:p>
-        </p:txBody>
-      </p:sp>
-      <p:sp>
-        <p:nvSpPr>
-          <p:cNvPr id="3" name="TextBox 2"/>
-          <p:cNvSpPr txBox="1"/>
-          <p:nvPr/>
-        </p:nvSpPr>
-        <p:spPr>
-          <a:xfrm>
-            <a:off x="640080" y="822960"/>
-            <a:ext cx="7863840" cy="731520"/>
-          </a:xfrm>
-          <a:prstGeom prst="rect">
-            <a:avLst/>
-          </a:prstGeom>
-          <a:noFill/>
-        </p:spPr>
-        <p:txBody>
-          <a:bodyPr wrap="none">
-            <a:spAutoFit/>
-          </a:bodyPr>
-          <a:lstStyle/>
-          <a:p>
-            <a:pPr>
-              <a:defRPr sz="3600" b="1">
+              <a:defRPr sz="1800">
                 <a:solidFill>
                   <a:srgbClr val="FFFFFF"/>
                 </a:solidFill>
               </a:defRPr>
             </a:pPr>
             <a:r>
-              <a:t>Свяжитесь с нами</a:t>
-            </a:r>
-          </a:p>
-        </p:txBody>
-      </p:sp>
-      <p:sp>
-        <p:nvSpPr>
-          <p:cNvPr id="4" name="TextBox 3"/>
-          <p:cNvSpPr txBox="1"/>
-          <p:nvPr/>
-        </p:nvSpPr>
-        <p:spPr>
-          <a:xfrm>
-            <a:off x="822960" y="1828800"/>
-            <a:ext cx="7498079" cy="2926080"/>
-          </a:xfrm>
-          <a:prstGeom prst="rect">
-            <a:avLst/>
-          </a:prstGeom>
-          <a:noFill/>
-        </p:spPr>
-        <p:txBody>
-          <a:bodyPr wrap="square">
-            <a:spAutoFit/>
-          </a:bodyPr>
-          <a:lstStyle/>
+              <a:t>ООО ТехноДиагностика</a:t>
+            </a:r>
+          </a:p>
           <a:p>
             <a:pPr>
               <a:spcAft>
-                <a:spcPts val="1200"/>
+                <a:spcPts val="1000"/>
               </a:spcAft>
-              <a:defRPr sz="2400">
+              <a:defRPr sz="1800">
                 <a:solidFill>
                   <a:srgbClr val="FFFFFF"/>
                 </a:solidFill>
               </a:defRPr>
             </a:pPr>
             <a:r>
-              <a:t>ООО ТехноДиагностика</a:t>
+              <a:t>+7 495 123-45-67</a:t>
             </a:r>
           </a:p>
           <a:p>
             <a:pPr>
               <a:spcAft>
-                <a:spcPts val="1200"/>
+                <a:spcPts val="1000"/>
               </a:spcAft>
-              <a:defRPr sz="2400">
+              <a:defRPr sz="1800">
                 <a:solidFill>
                   <a:srgbClr val="FFFFFF"/>
                 </a:solidFill>
               </a:defRPr>
             </a:pPr>
             <a:r>
-              <a:t>+7 495 123-45-67</a:t>
+              <a:t>info@techdiagnostika.ru</a:t>
             </a:r>
           </a:p>
           <a:p>
             <a:pPr>
               <a:spcAft>
-                <a:spcPts val="1200"/>
+                <a:spcPts val="1000"/>
               </a:spcAft>
-              <a:defRPr sz="2400">
+              <a:defRPr sz="1800">
                 <a:solidFill>
                   <a:srgbClr val="FFFFFF"/>
                 </a:solidFill>
               </a:defRPr>
             </a:pPr>
             <a:r>
-              <a:t>info@techdiagnostika.ru</a:t>
+              <a:t>techdiagnostika.ru</a:t>
             </a:r>
           </a:p>
           <a:p>
             <a:pPr>
               <a:spcAft>
-                <a:spcPts val="1200"/>
+                <a:spcPts val="1000"/>
               </a:spcAft>
-              <a:defRPr sz="2400">
+              <a:defRPr sz="1800">
                 <a:solidFill>
                   <a:srgbClr val="FFFFFF"/>
                 </a:solidFill>
               </a:defRPr>
             </a:pPr>
             <a:r>
-              <a:t>techdiagnostika.ru</a:t>
-            </a:r>
-          </a:p>
-          <a:p>
-            <a:pPr>
-              <a:spcAft>
-                <a:spcPts val="1200"/>
-              </a:spcAft>
-              <a:defRPr sz="2400">
-                <a:solidFill>
-                  <a:srgbClr val="FFFFFF"/>
-                </a:solidFill>
-              </a:defRPr>
-            </a:pPr>
-            <a:r>
               <a:t>Москва, ул. Примерная, 10</a:t>
             </a:r>
           </a:p>
         </p:txBody>
       </p:sp>
+      <p:pic>
+        <p:nvPicPr>
+          <p:cNvPr id="5" name="Picture 4" descr="logo.png"/>
+          <p:cNvPicPr>
+            <a:picLocks noChangeAspect="1"/>
+          </p:cNvPicPr>
+          <p:nvPr/>
+        </p:nvPicPr>
+        <p:blipFill>
+          <a:blip r:embed="rId2"/>
+          <a:stretch>
+            <a:fillRect/>
+          </a:stretch>
+        </p:blipFill>
+        <p:spPr>
+          <a:xfrm>
+            <a:off x="7101840" y="228600"/>
+            <a:ext cx="1676400" cy="502920"/>
+          </a:xfrm>
+          <a:prstGeom prst="rect">
+            <a:avLst/>
+          </a:prstGeom>
+        </p:spPr>
+      </p:pic>
     </p:spTree>
   </p:cSld>
   <p:clrMapOvr>

</xml_diff>